<commit_message>
Updated docs+cleaning up files
</commit_message>
<xml_diff>
--- a/docs/Eco-Loop_Idea_Submission.pptx
+++ b/docs/Eco-Loop_Idea_Submission.pptx
@@ -4993,7 +4993,7 @@
         <p:spPr>
           <a:xfrm>
             <a:off x="397273" y="549199"/>
-            <a:ext cx="11674983" cy="5425331"/>
+            <a:ext cx="11674983" cy="5434180"/>
           </a:xfrm>
           <a:prstGeom prst="rect">
             <a:avLst/>
@@ -5006,7 +5006,10 @@
           </a:bodyPr>
           <a:lstStyle/>
           <a:p>
-            <a:endParaRPr lang="en-US" dirty="0"/>
+            <a:endParaRPr lang="en-US" dirty="0">
+              <a:latin typeface="Arial" panose="020B0604020202020204" pitchFamily="34" charset="0"/>
+              <a:cs typeface="Arial" panose="020B0604020202020204" pitchFamily="34" charset="0"/>
+            </a:endParaRPr>
           </a:p>
           <a:p>
             <a:pPr marL="285750" indent="-285750" algn="just">
@@ -5021,7 +5024,14 @@
                 <a:latin typeface="Arial" panose="020B0604020202020204" pitchFamily="34" charset="0"/>
                 <a:cs typeface="Arial" panose="020B0604020202020204" pitchFamily="34" charset="0"/>
               </a:rPr>
-              <a:t>Problem Statement ID -</a:t>
+              <a:t>Problem Statement ID - </a:t>
+            </a:r>
+            <a:r>
+              <a:rPr lang="en-US" sz="2400" dirty="0">
+                <a:latin typeface="Arial" panose="020B0604020202020204" pitchFamily="34" charset="0"/>
+                <a:cs typeface="Arial" panose="020B0604020202020204" pitchFamily="34" charset="0"/>
+              </a:rPr>
+              <a:t>1</a:t>
             </a:r>
           </a:p>
           <a:p>
@@ -5040,10 +5050,20 @@
               <a:t>Problem Statement Title-</a:t>
             </a:r>
             <a:r>
-              <a:rPr lang="en-GB" sz="2400" dirty="0"/>
-              <a:t> Eco-Loop Building Agents: Autonomous Closed-Loop Building Energy Management</a:t>
-            </a:r>
-            <a:endParaRPr lang="en-US" sz="2400" b="1" dirty="0">
+              <a:rPr lang="en-GB" sz="2400" dirty="0">
+                <a:latin typeface="Arial" panose="020B0604020202020204" pitchFamily="34" charset="0"/>
+                <a:cs typeface="Arial" panose="020B0604020202020204" pitchFamily="34" charset="0"/>
+              </a:rPr>
+              <a:t> Eco-Loop Building Agents: </a:t>
+            </a:r>
+            <a:r>
+              <a:rPr lang="en-IN" sz="2400" dirty="0">
+                <a:latin typeface="Arial" panose="020B0604020202020204" pitchFamily="34" charset="0"/>
+                <a:cs typeface="Arial" panose="020B0604020202020204" pitchFamily="34" charset="0"/>
+              </a:rPr>
+              <a:t>AI-Powered Autonomous Smart Building Optimization Challenge</a:t>
+            </a:r>
+            <a:endParaRPr lang="en-US" sz="2400" dirty="0">
               <a:latin typeface="Arial" panose="020B0604020202020204" pitchFamily="34" charset="0"/>
               <a:cs typeface="Arial" panose="020B0604020202020204" pitchFamily="34" charset="0"/>
             </a:endParaRPr>
@@ -5063,6 +5083,17 @@
               </a:rPr>
               <a:t>Theme- </a:t>
             </a:r>
+            <a:r>
+              <a:rPr lang="en-GB" sz="2400" dirty="0">
+                <a:latin typeface="Arial" panose="020B0604020202020204" pitchFamily="34" charset="0"/>
+                <a:cs typeface="Arial" panose="020B0604020202020204" pitchFamily="34" charset="0"/>
+              </a:rPr>
+              <a:t>Clean &amp; Green Technology  (Smart Automation / Sustainable Energy)</a:t>
+            </a:r>
+            <a:endParaRPr lang="en-US" sz="2400" dirty="0">
+              <a:latin typeface="Arial" panose="020B0604020202020204" pitchFamily="34" charset="0"/>
+              <a:cs typeface="Arial" panose="020B0604020202020204" pitchFamily="34" charset="0"/>
+            </a:endParaRPr>
           </a:p>
           <a:p>
             <a:pPr marL="285750" indent="-285750" algn="just">
@@ -5080,7 +5111,10 @@
               <a:t>PS Category- </a:t>
             </a:r>
             <a:r>
-              <a:rPr lang="en-GB" sz="2400" dirty="0"/>
+              <a:rPr lang="en-GB" sz="2400" dirty="0">
+                <a:latin typeface="Arial" panose="020B0604020202020204" pitchFamily="34" charset="0"/>
+                <a:cs typeface="Arial" panose="020B0604020202020204" pitchFamily="34" charset="0"/>
+              </a:rPr>
               <a:t>Software</a:t>
             </a:r>
             <a:endParaRPr lang="en-US" sz="2400" b="1" dirty="0">
@@ -5104,7 +5138,10 @@
               <a:t>Student Name (Registered on portal)-</a:t>
             </a:r>
             <a:r>
-              <a:rPr lang="en-GB" sz="2400" dirty="0"/>
+              <a:rPr lang="en-GB" sz="2400" dirty="0">
+                <a:latin typeface="Arial" panose="020B0604020202020204" pitchFamily="34" charset="0"/>
+                <a:cs typeface="Arial" panose="020B0604020202020204" pitchFamily="34" charset="0"/>
+              </a:rPr>
               <a:t> Mahendra Kausik Vankadara</a:t>
             </a:r>
             <a:endParaRPr lang="en-US" sz="2400" b="1" dirty="0">
@@ -5128,7 +5165,10 @@
               <a:t>Student ID-</a:t>
             </a:r>
             <a:r>
-              <a:rPr lang="en-GB" sz="2400" dirty="0"/>
+              <a:rPr lang="en-GB" sz="2400" dirty="0">
+                <a:latin typeface="Arial" panose="020B0604020202020204" pitchFamily="34" charset="0"/>
+                <a:cs typeface="Arial" panose="020B0604020202020204" pitchFamily="34" charset="0"/>
+              </a:rPr>
               <a:t> PES1UG23AM163</a:t>
             </a:r>
             <a:endParaRPr lang="en-IN" sz="2400" b="1" dirty="0">
@@ -5681,8 +5721,8 @@
         </p:nvSpPr>
         <p:spPr bwMode="auto">
           <a:xfrm>
-            <a:off x="609600" y="846367"/>
-            <a:ext cx="10972800" cy="3170099"/>
+            <a:off x="152400" y="846367"/>
+            <a:ext cx="11430000" cy="2954655"/>
           </a:xfrm>
           <a:prstGeom prst="rect">
             <a:avLst/>
@@ -5701,51 +5741,246 @@
           </a:bodyPr>
           <a:lstStyle/>
           <a:p>
+            <a:r>
+              <a:rPr lang="en-US" sz="2000" b="1" u="sng" dirty="0">
+                <a:latin typeface="Arial" pitchFamily="34" charset="0"/>
+                <a:cs typeface="Arial" pitchFamily="34" charset="0"/>
+              </a:rPr>
+              <a:t>Technologies Used: </a:t>
+            </a:r>
+          </a:p>
+          <a:p>
             <a:pPr marL="457200" indent="-457200">
               <a:buFont typeface="Arial" panose="020B0604020202020204" pitchFamily="34" charset="0"/>
               <a:buChar char="•"/>
             </a:pPr>
             <a:r>
-              <a:rPr lang="en-US" sz="2000" b="1" dirty="0">
+              <a:rPr lang="en-US" b="1" dirty="0">
                 <a:latin typeface="Arial" pitchFamily="34" charset="0"/>
                 <a:cs typeface="Arial" pitchFamily="34" charset="0"/>
               </a:rPr>
               <a:t>Python 3.11; </a:t>
             </a:r>
             <a:r>
-              <a:rPr lang="en-US" sz="2000" b="1" dirty="0" err="1">
+              <a:rPr lang="en-US" b="1" dirty="0" err="1">
                 <a:latin typeface="Arial" pitchFamily="34" charset="0"/>
                 <a:cs typeface="Arial" pitchFamily="34" charset="0"/>
               </a:rPr>
               <a:t>EnergyPlus</a:t>
             </a:r>
             <a:r>
-              <a:rPr lang="en-US" sz="2000" b="1" dirty="0">
+              <a:rPr lang="en-US" b="1" dirty="0">
                 <a:latin typeface="Arial" pitchFamily="34" charset="0"/>
                 <a:cs typeface="Arial" pitchFamily="34" charset="0"/>
               </a:rPr>
               <a:t> 26.1 </a:t>
             </a:r>
             <a:r>
-              <a:rPr lang="en-US" sz="2000" dirty="0">
+              <a:rPr lang="en-US" dirty="0">
                 <a:latin typeface="Arial" pitchFamily="34" charset="0"/>
                 <a:cs typeface="Arial" pitchFamily="34" charset="0"/>
               </a:rPr>
               <a:t>driven through its bundled </a:t>
             </a:r>
             <a:r>
-              <a:rPr lang="en-US" sz="2000" dirty="0" err="1">
+              <a:rPr lang="en-US" dirty="0" err="1">
                 <a:latin typeface="Arial" pitchFamily="34" charset="0"/>
                 <a:cs typeface="Arial" pitchFamily="34" charset="0"/>
               </a:rPr>
               <a:t>pyenergyplus</a:t>
             </a:r>
             <a:r>
-              <a:rPr lang="en-US" sz="2000" dirty="0">
+              <a:rPr lang="en-US" dirty="0">
                 <a:latin typeface="Arial" pitchFamily="34" charset="0"/>
                 <a:cs typeface="Arial" pitchFamily="34" charset="0"/>
               </a:rPr>
               <a:t> runtime API with in-process callbacks (not file-rewrite-and-rerun, not FMU/BCVTB)</a:t>
+            </a:r>
+          </a:p>
+          <a:p>
+            <a:pPr marL="457200" indent="-457200">
+              <a:buFont typeface="Arial" panose="020B0604020202020204" pitchFamily="34" charset="0"/>
+              <a:buChar char="•"/>
+            </a:pPr>
+            <a:r>
+              <a:rPr lang="en-US" b="1" dirty="0">
+                <a:latin typeface="Arial" pitchFamily="34" charset="0"/>
+                <a:cs typeface="Arial" pitchFamily="34" charset="0"/>
+              </a:rPr>
+              <a:t>gpt-oss-120b</a:t>
+            </a:r>
+            <a:r>
+              <a:rPr lang="en-US" dirty="0">
+                <a:latin typeface="Arial" pitchFamily="34" charset="0"/>
+                <a:cs typeface="Arial" pitchFamily="34" charset="0"/>
+              </a:rPr>
+              <a:t> (OpenAI open-weight), served OpenAI-compatible on </a:t>
+            </a:r>
+            <a:r>
+              <a:rPr lang="en-US" b="1" dirty="0" err="1">
+                <a:latin typeface="Arial" pitchFamily="34" charset="0"/>
+                <a:cs typeface="Arial" pitchFamily="34" charset="0"/>
+              </a:rPr>
+              <a:t>Cerebras+Groq</a:t>
+            </a:r>
+            <a:r>
+              <a:rPr lang="en-US" b="1" dirty="0">
+                <a:latin typeface="Arial" pitchFamily="34" charset="0"/>
+                <a:cs typeface="Arial" pitchFamily="34" charset="0"/>
+              </a:rPr>
+              <a:t>, round </a:t>
+            </a:r>
+            <a:r>
+              <a:rPr lang="en-US" b="1" dirty="0" err="1">
+                <a:latin typeface="Arial" pitchFamily="34" charset="0"/>
+                <a:cs typeface="Arial" pitchFamily="34" charset="0"/>
+              </a:rPr>
+              <a:t>robined</a:t>
+            </a:r>
+            <a:r>
+              <a:rPr lang="en-US" b="1" dirty="0">
+                <a:latin typeface="Arial" pitchFamily="34" charset="0"/>
+                <a:cs typeface="Arial" pitchFamily="34" charset="0"/>
+              </a:rPr>
+              <a:t> </a:t>
+            </a:r>
+            <a:r>
+              <a:rPr lang="en-US" dirty="0">
+                <a:latin typeface="Arial" pitchFamily="34" charset="0"/>
+                <a:cs typeface="Arial" pitchFamily="34" charset="0"/>
+              </a:rPr>
+              <a:t>per call; local </a:t>
+            </a:r>
+            <a:r>
+              <a:rPr lang="en-US" b="1" dirty="0" err="1">
+                <a:latin typeface="Arial" pitchFamily="34" charset="0"/>
+                <a:cs typeface="Arial" pitchFamily="34" charset="0"/>
+              </a:rPr>
+              <a:t>Ollama</a:t>
+            </a:r>
+            <a:r>
+              <a:rPr lang="en-US" dirty="0">
+                <a:latin typeface="Arial" pitchFamily="34" charset="0"/>
+                <a:cs typeface="Arial" pitchFamily="34" charset="0"/>
+              </a:rPr>
+              <a:t> documented as a fully offline option</a:t>
+            </a:r>
+          </a:p>
+          <a:p>
+            <a:pPr marL="457200" indent="-457200">
+              <a:buFont typeface="Arial" panose="020B0604020202020204" pitchFamily="34" charset="0"/>
+              <a:buChar char="•"/>
+            </a:pPr>
+            <a:r>
+              <a:rPr lang="en-US" b="1" dirty="0" err="1">
+                <a:latin typeface="Arial" pitchFamily="34" charset="0"/>
+                <a:cs typeface="Arial" pitchFamily="34" charset="0"/>
+              </a:rPr>
+              <a:t>FastMCP</a:t>
+            </a:r>
+            <a:r>
+              <a:rPr lang="en-US" b="1" dirty="0">
+                <a:latin typeface="Arial" pitchFamily="34" charset="0"/>
+                <a:cs typeface="Arial" pitchFamily="34" charset="0"/>
+              </a:rPr>
+              <a:t>: </a:t>
+            </a:r>
+            <a:r>
+              <a:rPr lang="en-US" dirty="0">
+                <a:latin typeface="Arial" pitchFamily="34" charset="0"/>
+                <a:cs typeface="Arial" pitchFamily="34" charset="0"/>
+              </a:rPr>
+              <a:t>MCP server exposing the same 5 tools; </a:t>
+            </a:r>
+            <a:r>
+              <a:rPr lang="en-US" b="1" dirty="0" err="1">
+                <a:latin typeface="Arial" pitchFamily="34" charset="0"/>
+                <a:cs typeface="Arial" pitchFamily="34" charset="0"/>
+              </a:rPr>
+              <a:t>Pydantic</a:t>
+            </a:r>
+            <a:r>
+              <a:rPr lang="en-US" dirty="0">
+                <a:latin typeface="Arial" pitchFamily="34" charset="0"/>
+                <a:cs typeface="Arial" pitchFamily="34" charset="0"/>
+              </a:rPr>
+              <a:t> for strict-JSON decision validation; </a:t>
+            </a:r>
+            <a:r>
+              <a:rPr lang="en-US" b="1" dirty="0" err="1">
+                <a:latin typeface="Arial" pitchFamily="34" charset="0"/>
+                <a:cs typeface="Arial" pitchFamily="34" charset="0"/>
+              </a:rPr>
+              <a:t>Plotly</a:t>
+            </a:r>
+            <a:r>
+              <a:rPr lang="en-US" dirty="0">
+                <a:latin typeface="Arial" pitchFamily="34" charset="0"/>
+                <a:cs typeface="Arial" pitchFamily="34" charset="0"/>
+              </a:rPr>
+              <a:t> for the self-contained offline dashboard; </a:t>
+            </a:r>
+            <a:r>
+              <a:rPr lang="en-US" b="1" dirty="0">
+                <a:latin typeface="Arial" pitchFamily="34" charset="0"/>
+                <a:cs typeface="Arial" pitchFamily="34" charset="0"/>
+              </a:rPr>
+              <a:t>pandas/</a:t>
+            </a:r>
+            <a:r>
+              <a:rPr lang="en-US" b="1" dirty="0" err="1">
+                <a:latin typeface="Arial" pitchFamily="34" charset="0"/>
+                <a:cs typeface="Arial" pitchFamily="34" charset="0"/>
+              </a:rPr>
+              <a:t>numpy</a:t>
+            </a:r>
+            <a:r>
+              <a:rPr lang="en-US" b="1" dirty="0">
+                <a:latin typeface="Arial" pitchFamily="34" charset="0"/>
+                <a:cs typeface="Arial" pitchFamily="34" charset="0"/>
+              </a:rPr>
+              <a:t> </a:t>
+            </a:r>
+            <a:r>
+              <a:rPr lang="en-US" dirty="0">
+                <a:latin typeface="Arial" pitchFamily="34" charset="0"/>
+                <a:cs typeface="Arial" pitchFamily="34" charset="0"/>
+              </a:rPr>
+              <a:t>for metrics</a:t>
+            </a:r>
+          </a:p>
+          <a:p>
+            <a:pPr marL="457200" indent="-457200">
+              <a:buFont typeface="Arial" panose="020B0604020202020204" pitchFamily="34" charset="0"/>
+              <a:buChar char="•"/>
+            </a:pPr>
+            <a:r>
+              <a:rPr lang="en-US" b="1" dirty="0">
+                <a:latin typeface="Arial" pitchFamily="34" charset="0"/>
+                <a:cs typeface="Arial" pitchFamily="34" charset="0"/>
+              </a:rPr>
+              <a:t>Building model: </a:t>
+            </a:r>
+            <a:r>
+              <a:rPr lang="en-US" dirty="0">
+                <a:latin typeface="Arial" pitchFamily="34" charset="0"/>
+                <a:cs typeface="Arial" pitchFamily="34" charset="0"/>
+              </a:rPr>
+              <a:t>shipped </a:t>
+            </a:r>
+            <a:r>
+              <a:rPr lang="en-US" b="1" dirty="0">
+                <a:latin typeface="Arial" pitchFamily="34" charset="0"/>
+                <a:cs typeface="Arial" pitchFamily="34" charset="0"/>
+              </a:rPr>
+              <a:t>5ZoneAirCooled.idf</a:t>
+            </a:r>
+            <a:r>
+              <a:rPr lang="en-US" dirty="0">
+                <a:latin typeface="Arial" pitchFamily="34" charset="0"/>
+                <a:cs typeface="Arial" pitchFamily="34" charset="0"/>
+              </a:rPr>
+              <a:t>, Chicago TMY3 weather, 15-21 July</a:t>
             </a:r>
           </a:p>
           <a:p>
@@ -5759,202 +5994,12 @@
             </a:endParaRPr>
           </a:p>
           <a:p>
-            <a:pPr marL="457200" indent="-457200">
-              <a:buFont typeface="Arial" panose="020B0604020202020204" pitchFamily="34" charset="0"/>
-              <a:buChar char="•"/>
-            </a:pPr>
-            <a:r>
-              <a:rPr lang="en-US" sz="2000" b="1" dirty="0">
-                <a:latin typeface="Arial" pitchFamily="34" charset="0"/>
-                <a:cs typeface="Arial" pitchFamily="34" charset="0"/>
-              </a:rPr>
-              <a:t>gpt-oss-120b</a:t>
-            </a:r>
-            <a:r>
-              <a:rPr lang="en-US" sz="2000" dirty="0">
-                <a:latin typeface="Arial" pitchFamily="34" charset="0"/>
-                <a:cs typeface="Arial" pitchFamily="34" charset="0"/>
-              </a:rPr>
-              <a:t> (OpenAI open-weight), served OpenAI-compatible on </a:t>
-            </a:r>
-            <a:r>
-              <a:rPr lang="en-US" sz="2000" b="1" dirty="0" err="1">
-                <a:latin typeface="Arial" pitchFamily="34" charset="0"/>
-                <a:cs typeface="Arial" pitchFamily="34" charset="0"/>
-              </a:rPr>
-              <a:t>Cerebras+Groq</a:t>
-            </a:r>
-            <a:r>
-              <a:rPr lang="en-US" sz="2000" b="1" dirty="0">
-                <a:latin typeface="Arial" pitchFamily="34" charset="0"/>
-                <a:cs typeface="Arial" pitchFamily="34" charset="0"/>
-              </a:rPr>
-              <a:t>, round </a:t>
-            </a:r>
-            <a:r>
-              <a:rPr lang="en-US" sz="2000" b="1" dirty="0" err="1">
-                <a:latin typeface="Arial" pitchFamily="34" charset="0"/>
-                <a:cs typeface="Arial" pitchFamily="34" charset="0"/>
-              </a:rPr>
-              <a:t>robined</a:t>
-            </a:r>
-            <a:r>
-              <a:rPr lang="en-US" sz="2000" b="1" dirty="0">
-                <a:latin typeface="Arial" pitchFamily="34" charset="0"/>
-                <a:cs typeface="Arial" pitchFamily="34" charset="0"/>
-              </a:rPr>
-              <a:t> </a:t>
-            </a:r>
-            <a:r>
-              <a:rPr lang="en-US" sz="2000" dirty="0">
-                <a:latin typeface="Arial" pitchFamily="34" charset="0"/>
-                <a:cs typeface="Arial" pitchFamily="34" charset="0"/>
-              </a:rPr>
-              <a:t>per call; local </a:t>
-            </a:r>
-            <a:r>
-              <a:rPr lang="en-US" sz="2000" b="1" dirty="0" err="1">
-                <a:latin typeface="Arial" pitchFamily="34" charset="0"/>
-                <a:cs typeface="Arial" pitchFamily="34" charset="0"/>
-              </a:rPr>
-              <a:t>Ollama</a:t>
-            </a:r>
-            <a:r>
-              <a:rPr lang="en-US" sz="2000" dirty="0">
-                <a:latin typeface="Arial" pitchFamily="34" charset="0"/>
-                <a:cs typeface="Arial" pitchFamily="34" charset="0"/>
-              </a:rPr>
-              <a:t> documented as a fully offline option</a:t>
-            </a:r>
-          </a:p>
-          <a:p>
-            <a:pPr marL="457200" indent="-457200">
-              <a:buFont typeface="Arial" panose="020B0604020202020204" pitchFamily="34" charset="0"/>
-              <a:buChar char="•"/>
-            </a:pPr>
-            <a:endParaRPr lang="en-US" sz="2000" dirty="0">
-              <a:latin typeface="Arial" pitchFamily="34" charset="0"/>
-              <a:cs typeface="Arial" pitchFamily="34" charset="0"/>
-            </a:endParaRPr>
-          </a:p>
-          <a:p>
-            <a:pPr marL="457200" indent="-457200">
-              <a:buFont typeface="Arial" panose="020B0604020202020204" pitchFamily="34" charset="0"/>
-              <a:buChar char="•"/>
-            </a:pPr>
-            <a:r>
-              <a:rPr lang="en-US" sz="2000" b="1" dirty="0" err="1">
-                <a:latin typeface="Arial" pitchFamily="34" charset="0"/>
-                <a:cs typeface="Arial" pitchFamily="34" charset="0"/>
-              </a:rPr>
-              <a:t>FastMCP</a:t>
-            </a:r>
-            <a:r>
-              <a:rPr lang="en-US" sz="2000" b="1" dirty="0">
-                <a:latin typeface="Arial" pitchFamily="34" charset="0"/>
-                <a:cs typeface="Arial" pitchFamily="34" charset="0"/>
-              </a:rPr>
-              <a:t>: </a:t>
-            </a:r>
-            <a:r>
-              <a:rPr lang="en-US" sz="2000" dirty="0">
-                <a:latin typeface="Arial" pitchFamily="34" charset="0"/>
-                <a:cs typeface="Arial" pitchFamily="34" charset="0"/>
-              </a:rPr>
-              <a:t>MCP server exposing the same 5 tools; </a:t>
-            </a:r>
-            <a:r>
-              <a:rPr lang="en-US" sz="2000" b="1" dirty="0" err="1">
-                <a:latin typeface="Arial" pitchFamily="34" charset="0"/>
-                <a:cs typeface="Arial" pitchFamily="34" charset="0"/>
-              </a:rPr>
-              <a:t>Pydantic</a:t>
-            </a:r>
-            <a:r>
-              <a:rPr lang="en-US" sz="2000" dirty="0">
-                <a:latin typeface="Arial" pitchFamily="34" charset="0"/>
-                <a:cs typeface="Arial" pitchFamily="34" charset="0"/>
-              </a:rPr>
-              <a:t> for strict-JSON decision validation; </a:t>
-            </a:r>
-            <a:r>
-              <a:rPr lang="en-US" sz="2000" b="1" dirty="0" err="1">
-                <a:latin typeface="Arial" pitchFamily="34" charset="0"/>
-                <a:cs typeface="Arial" pitchFamily="34" charset="0"/>
-              </a:rPr>
-              <a:t>Plotly</a:t>
-            </a:r>
-            <a:r>
-              <a:rPr lang="en-US" sz="2000" dirty="0">
-                <a:latin typeface="Arial" pitchFamily="34" charset="0"/>
-                <a:cs typeface="Arial" pitchFamily="34" charset="0"/>
-              </a:rPr>
-              <a:t> for the self-contained offline dashboard; </a:t>
-            </a:r>
-            <a:r>
-              <a:rPr lang="en-US" sz="2000" b="1" dirty="0">
-                <a:latin typeface="Arial" pitchFamily="34" charset="0"/>
-                <a:cs typeface="Arial" pitchFamily="34" charset="0"/>
-              </a:rPr>
-              <a:t>pandas/</a:t>
-            </a:r>
-            <a:r>
-              <a:rPr lang="en-US" sz="2000" b="1" dirty="0" err="1">
-                <a:latin typeface="Arial" pitchFamily="34" charset="0"/>
-                <a:cs typeface="Arial" pitchFamily="34" charset="0"/>
-              </a:rPr>
-              <a:t>numpy</a:t>
-            </a:r>
-            <a:r>
-              <a:rPr lang="en-US" sz="2000" b="1" dirty="0">
-                <a:latin typeface="Arial" pitchFamily="34" charset="0"/>
-                <a:cs typeface="Arial" pitchFamily="34" charset="0"/>
-              </a:rPr>
-              <a:t> </a:t>
-            </a:r>
-            <a:r>
-              <a:rPr lang="en-US" sz="2000" dirty="0">
-                <a:latin typeface="Arial" pitchFamily="34" charset="0"/>
-                <a:cs typeface="Arial" pitchFamily="34" charset="0"/>
-              </a:rPr>
-              <a:t>for metrics</a:t>
-            </a:r>
-          </a:p>
-          <a:p>
-            <a:pPr marL="457200" indent="-457200">
-              <a:buFont typeface="Arial" panose="020B0604020202020204" pitchFamily="34" charset="0"/>
-              <a:buChar char="•"/>
-            </a:pPr>
-            <a:endParaRPr lang="en-US" sz="2000" dirty="0">
-              <a:latin typeface="Arial" pitchFamily="34" charset="0"/>
-              <a:cs typeface="Arial" pitchFamily="34" charset="0"/>
-            </a:endParaRPr>
-          </a:p>
-          <a:p>
-            <a:pPr marL="457200" indent="-457200">
-              <a:buFont typeface="Arial" panose="020B0604020202020204" pitchFamily="34" charset="0"/>
-              <a:buChar char="•"/>
-            </a:pPr>
-            <a:r>
-              <a:rPr lang="en-US" sz="2000" dirty="0">
-                <a:latin typeface="Arial" pitchFamily="34" charset="0"/>
-                <a:cs typeface="Arial" pitchFamily="34" charset="0"/>
-              </a:rPr>
-              <a:t>Building model: shipped </a:t>
-            </a:r>
-            <a:r>
-              <a:rPr lang="en-US" sz="2000" b="1" dirty="0">
-                <a:latin typeface="Arial" pitchFamily="34" charset="0"/>
-                <a:cs typeface="Arial" pitchFamily="34" charset="0"/>
-              </a:rPr>
-              <a:t>5ZoneAirCooled.idf</a:t>
-            </a:r>
-            <a:r>
-              <a:rPr lang="en-US" sz="2000" dirty="0">
-                <a:latin typeface="Arial" pitchFamily="34" charset="0"/>
-                <a:cs typeface="Arial" pitchFamily="34" charset="0"/>
-              </a:rPr>
-              <a:t>, Chicago TMY3 weather, 15-21 July</a:t>
+            <a:r>
+              <a:rPr lang="en-US" sz="2000" b="1" u="sng" dirty="0">
+                <a:latin typeface="Arial" pitchFamily="34" charset="0"/>
+                <a:cs typeface="Arial" pitchFamily="34" charset="0"/>
+              </a:rPr>
+              <a:t>Methodology:</a:t>
             </a:r>
           </a:p>
         </p:txBody>
@@ -6052,8 +6097,8 @@
         </p:blipFill>
         <p:spPr>
           <a:xfrm>
-            <a:off x="0" y="4217874"/>
-            <a:ext cx="12192000" cy="2324440"/>
+            <a:off x="337456" y="3916467"/>
+            <a:ext cx="11430000" cy="2614962"/>
           </a:xfrm>
           <a:prstGeom prst="rect">
             <a:avLst/>
@@ -6127,8 +6172,8 @@
         </p:nvSpPr>
         <p:spPr bwMode="auto">
           <a:xfrm>
-            <a:off x="1083128" y="633422"/>
-            <a:ext cx="10025743" cy="6247864"/>
+            <a:off x="713015" y="668130"/>
+            <a:ext cx="10765970" cy="6001643"/>
           </a:xfrm>
           <a:prstGeom prst="rect">
             <a:avLst/>
@@ -6160,7 +6205,7 @@
                 <a:latin typeface="Arial" pitchFamily="34" charset="0"/>
                 <a:cs typeface="Arial" pitchFamily="34" charset="0"/>
               </a:rPr>
-              <a:t>Feasibility: measured, not projected</a:t>
+              <a:t>Feasibility (Measured, not projected):</a:t>
             </a:r>
           </a:p>
           <a:p>
@@ -6234,7 +6279,7 @@
                 <a:latin typeface="Arial" pitchFamily="34" charset="0"/>
                 <a:cs typeface="Arial" pitchFamily="34" charset="0"/>
               </a:rPr>
-              <a:t>Reliability soak: 14 simulated days (2x the required horizon), 336/336 decisions, zero crashes</a:t>
+              <a:t>Reliability soak: 14 simulated days (2× the required horizon) with the LLM live throughout- 336/336 decisions injected, 0/336 fell back to the rule schedule, 0 crashes, </a:t>
             </a:r>
             <a:r>
               <a:rPr lang="en-GB" sz="1600" dirty="0">
@@ -6244,7 +6289,7 @@
                 <a:latin typeface="Arial" pitchFamily="34" charset="0"/>
                 <a:cs typeface="Arial" pitchFamily="34" charset="0"/>
               </a:rPr>
-              <a:t>. </a:t>
+              <a:t>latency p50 693ms / p95 1641ms, and 92.9% occupied comfort held across the full 14 days.</a:t>
             </a:r>
           </a:p>
           <a:p>
@@ -6897,7 +6942,7 @@
         <p:spPr bwMode="auto">
           <a:xfrm>
             <a:off x="609600" y="863542"/>
-            <a:ext cx="10972800" cy="2308324"/>
+            <a:ext cx="10972800" cy="2369880"/>
           </a:xfrm>
           <a:prstGeom prst="rect">
             <a:avLst/>
@@ -6922,7 +6967,7 @@
               <a:defRPr/>
             </a:pPr>
             <a:r>
-              <a:rPr lang="en-US" b="1" dirty="0">
+              <a:rPr lang="en-US" sz="1600" b="1" dirty="0">
                 <a:solidFill>
                   <a:prstClr val="black"/>
                 </a:solidFill>
@@ -6932,7 +6977,7 @@
               <a:t>Full source: </a:t>
             </a:r>
             <a:r>
-              <a:rPr lang="en-US" dirty="0">
+              <a:rPr lang="en-US" sz="1600" dirty="0">
                 <a:solidFill>
                   <a:prstClr val="black"/>
                 </a:solidFill>
@@ -6942,7 +6987,7 @@
               </a:rPr>
               <a:t>https://github.com/mahendra-kausik/eco-loop-building-agents</a:t>
             </a:r>
-            <a:endParaRPr lang="en-US" dirty="0">
+            <a:endParaRPr lang="en-US" sz="1600" dirty="0">
               <a:solidFill>
                 <a:prstClr val="black"/>
               </a:solidFill>
@@ -6957,7 +7002,7 @@
               <a:defRPr/>
             </a:pPr>
             <a:r>
-              <a:rPr lang="en-US" b="1" dirty="0">
+              <a:rPr lang="en-US" sz="1600" b="1" dirty="0">
                 <a:solidFill>
                   <a:prstClr val="black"/>
                 </a:solidFill>
@@ -6967,7 +7012,7 @@
               <a:t>Architecture doc: </a:t>
             </a:r>
             <a:r>
-              <a:rPr lang="en-US" dirty="0">
+              <a:rPr lang="en-US" sz="1600" dirty="0">
                 <a:solidFill>
                   <a:prstClr val="black"/>
                 </a:solidFill>
@@ -6984,7 +7029,7 @@
               <a:defRPr/>
             </a:pPr>
             <a:r>
-              <a:rPr lang="en-US" b="1" dirty="0">
+              <a:rPr lang="en-US" sz="1600" b="1" dirty="0">
                 <a:solidFill>
                   <a:prstClr val="black"/>
                 </a:solidFill>
@@ -6994,7 +7039,7 @@
               <a:t>Dashboard:</a:t>
             </a:r>
             <a:r>
-              <a:rPr lang="en-US" dirty="0">
+              <a:rPr lang="en-US" sz="1600" dirty="0">
                 <a:solidFill>
                   <a:prstClr val="black"/>
                 </a:solidFill>
@@ -7011,7 +7056,7 @@
               <a:defRPr/>
             </a:pPr>
             <a:r>
-              <a:rPr lang="en-US" b="1" dirty="0">
+              <a:rPr lang="en-US" sz="1600" b="1" dirty="0">
                 <a:solidFill>
                   <a:prstClr val="black"/>
                 </a:solidFill>
@@ -7021,7 +7066,7 @@
               <a:t>Building models: </a:t>
             </a:r>
             <a:r>
-              <a:rPr lang="en-US" dirty="0">
+              <a:rPr lang="en-US" sz="1600" dirty="0">
                 <a:solidFill>
                   <a:prstClr val="black"/>
                 </a:solidFill>
@@ -7031,7 +7076,7 @@
               <a:t>models/</a:t>
             </a:r>
             <a:r>
-              <a:rPr lang="en-US" dirty="0" err="1">
+              <a:rPr lang="en-US" sz="1600" dirty="0" err="1">
                 <a:solidFill>
                   <a:prstClr val="black"/>
                 </a:solidFill>
@@ -7041,7 +7086,7 @@
               <a:t>baseline.idf</a:t>
             </a:r>
             <a:r>
-              <a:rPr lang="en-US" dirty="0">
+              <a:rPr lang="en-US" sz="1600" dirty="0">
                 <a:solidFill>
                   <a:prstClr val="black"/>
                 </a:solidFill>
@@ -7051,7 +7096,7 @@
               <a:t> + </a:t>
             </a:r>
             <a:r>
-              <a:rPr lang="en-US" dirty="0" err="1">
+              <a:rPr lang="en-US" sz="1600" dirty="0" err="1">
                 <a:solidFill>
                   <a:prstClr val="black"/>
                 </a:solidFill>
@@ -7061,7 +7106,7 @@
               <a:t>agent_llm_runtime.idf</a:t>
             </a:r>
             <a:r>
-              <a:rPr lang="en-US" dirty="0">
+              <a:rPr lang="en-US" sz="1600" dirty="0">
                 <a:solidFill>
                   <a:prstClr val="black"/>
                 </a:solidFill>
@@ -7071,7 +7116,7 @@
               <a:t> / </a:t>
             </a:r>
             <a:r>
-              <a:rPr lang="en-US" dirty="0" err="1">
+              <a:rPr lang="en-US" sz="1600" dirty="0" err="1">
                 <a:solidFill>
                   <a:prstClr val="black"/>
                 </a:solidFill>
@@ -7081,7 +7126,7 @@
               <a:t>agent_fallback_runtime.idf</a:t>
             </a:r>
             <a:r>
-              <a:rPr lang="en-US" dirty="0">
+              <a:rPr lang="en-US" sz="1600" dirty="0">
                 <a:solidFill>
                   <a:prstClr val="black"/>
                 </a:solidFill>
@@ -7091,7 +7136,7 @@
               <a:t> (</a:t>
             </a:r>
             <a:r>
-              <a:rPr lang="en-GB" dirty="0">
+              <a:rPr lang="en-GB" sz="1600" dirty="0">
                 <a:solidFill>
                   <a:prstClr val="black"/>
                 </a:solidFill>
@@ -7100,7 +7145,7 @@
               </a:rPr>
               <a:t>the actual applied hour-by-hour schedules baked into real IDF objects, diffable against baseline)</a:t>
             </a:r>
-            <a:endParaRPr lang="en-US" dirty="0">
+            <a:endParaRPr lang="en-US" sz="1600" dirty="0">
               <a:solidFill>
                 <a:prstClr val="black"/>
               </a:solidFill>
@@ -7115,7 +7160,7 @@
               <a:defRPr/>
             </a:pPr>
             <a:r>
-              <a:rPr lang="en-US" b="1" dirty="0">
+              <a:rPr lang="en-US" sz="1600" b="1" dirty="0">
                 <a:solidFill>
                   <a:prstClr val="black"/>
                 </a:solidFill>
@@ -7125,7 +7170,7 @@
               <a:t>Decision log:</a:t>
             </a:r>
             <a:r>
-              <a:rPr lang="en-US" dirty="0">
+              <a:rPr lang="en-US" sz="1600" dirty="0">
                 <a:solidFill>
                   <a:prstClr val="black"/>
                 </a:solidFill>
@@ -7135,7 +7180,7 @@
               <a:t> results/</a:t>
             </a:r>
             <a:r>
-              <a:rPr lang="en-US" dirty="0" err="1">
+              <a:rPr lang="en-US" sz="1600" dirty="0" err="1">
                 <a:solidFill>
                   <a:prstClr val="black"/>
                 </a:solidFill>
@@ -7145,7 +7190,7 @@
               <a:t>decision_log.jsonl</a:t>
             </a:r>
             <a:r>
-              <a:rPr lang="en-US" dirty="0">
+              <a:rPr lang="en-US" sz="1600" dirty="0">
                 <a:solidFill>
                   <a:prstClr val="black"/>
                 </a:solidFill>
@@ -7155,7 +7200,7 @@
               <a:t> (168 decisions with the model's own stated reasoning) + </a:t>
             </a:r>
             <a:r>
-              <a:rPr lang="en-US" dirty="0" err="1">
+              <a:rPr lang="en-US" sz="1600" dirty="0" err="1">
                 <a:solidFill>
                   <a:prstClr val="black"/>
                 </a:solidFill>
@@ -7165,7 +7210,7 @@
               <a:t>decision_log_llm_unreachable.jsonl</a:t>
             </a:r>
             <a:r>
-              <a:rPr lang="en-US" dirty="0">
+              <a:rPr lang="en-US" sz="1600" dirty="0">
                 <a:solidFill>
                   <a:prstClr val="black"/>
                 </a:solidFill>
@@ -7174,7 +7219,34 @@
               </a:rPr>
               <a:t> (the 100%-fallback proof run)</a:t>
             </a:r>
-            <a:endParaRPr kumimoji="0" lang="en-US" b="0" i="0" u="none" strike="noStrike" kern="1200" cap="none" spc="0" normalizeH="0" baseline="0" noProof="0" dirty="0">
+          </a:p>
+          <a:p>
+            <a:pPr marL="342900" lvl="0" indent="-342900">
+              <a:buFont typeface="Arial" panose="020B0604020202020204" pitchFamily="34" charset="0"/>
+              <a:buChar char="•"/>
+              <a:defRPr/>
+            </a:pPr>
+            <a:r>
+              <a:rPr lang="en-US" sz="1600" b="1" dirty="0">
+                <a:solidFill>
+                  <a:prstClr val="black"/>
+                </a:solidFill>
+                <a:latin typeface="Arial" pitchFamily="34" charset="0"/>
+                <a:cs typeface="Arial" pitchFamily="34" charset="0"/>
+              </a:rPr>
+              <a:t>Reliability soak log: </a:t>
+            </a:r>
+            <a:r>
+              <a:rPr lang="en-US" sz="1600" dirty="0">
+                <a:solidFill>
+                  <a:prstClr val="black"/>
+                </a:solidFill>
+                <a:latin typeface="Arial" pitchFamily="34" charset="0"/>
+                <a:cs typeface="Arial" pitchFamily="34" charset="0"/>
+              </a:rPr>
+              <a:t>results/decision_log_soak14.jsonl (336 decisions, 14 simulated days, 0 fallbacks) plus the soak strip on results/dashboard.html</a:t>
+            </a:r>
+            <a:endParaRPr kumimoji="0" lang="en-US" sz="1600" b="0" i="0" u="none" strike="noStrike" kern="1200" cap="none" spc="0" normalizeH="0" baseline="0" noProof="0" dirty="0">
               <a:ln>
                 <a:noFill/>
               </a:ln>
@@ -7372,14 +7444,14 @@
           <p:nvPr>
             <p:extLst>
               <p:ext uri="{D42A27DB-BD31-4B8C-83A1-F6EECF244321}">
-                <p14:modId xmlns:p14="http://schemas.microsoft.com/office/powerpoint/2010/main" val="3634140663"/>
+                <p14:modId xmlns:p14="http://schemas.microsoft.com/office/powerpoint/2010/main" val="3208526968"/>
               </p:ext>
             </p:extLst>
           </p:nvPr>
         </p:nvGraphicFramePr>
         <p:xfrm>
-          <a:off x="1442651" y="3171866"/>
-          <a:ext cx="9306697" cy="3645847"/>
+          <a:off x="571500" y="3310500"/>
+          <a:ext cx="11048999" cy="3410978"/>
         </p:xfrm>
         <a:graphic>
           <a:graphicData uri="http://schemas.openxmlformats.org/drawingml/2006/table">
@@ -7388,28 +7460,28 @@
                 <a:tableStyleId>{5C22544A-7EE6-4342-B048-85BDC9FD1C3A}</a:tableStyleId>
               </a:tblPr>
               <a:tblGrid>
-                <a:gridCol w="3363685">
+                <a:gridCol w="3993399">
                   <a:extLst>
                     <a:ext uri="{9D8B030D-6E8A-4147-A177-3AD203B41FA5}">
                       <a16:colId xmlns:a16="http://schemas.microsoft.com/office/drawing/2014/main" val="243089259"/>
                     </a:ext>
                   </a:extLst>
                 </a:gridCol>
-                <a:gridCol w="1393372">
+                <a:gridCol w="1654225">
                   <a:extLst>
                     <a:ext uri="{9D8B030D-6E8A-4147-A177-3AD203B41FA5}">
                       <a16:colId xmlns:a16="http://schemas.microsoft.com/office/drawing/2014/main" val="2530782598"/>
                     </a:ext>
                   </a:extLst>
                 </a:gridCol>
-                <a:gridCol w="1491343">
+                <a:gridCol w="1770536">
                   <a:extLst>
                     <a:ext uri="{9D8B030D-6E8A-4147-A177-3AD203B41FA5}">
                       <a16:colId xmlns:a16="http://schemas.microsoft.com/office/drawing/2014/main" val="250388775"/>
                     </a:ext>
                   </a:extLst>
                 </a:gridCol>
-                <a:gridCol w="3058297">
+                <a:gridCol w="3630839">
                   <a:extLst>
                     <a:ext uri="{9D8B030D-6E8A-4147-A177-3AD203B41FA5}">
                       <a16:colId xmlns:a16="http://schemas.microsoft.com/office/drawing/2014/main" val="1470385253"/>
@@ -7417,7 +7489,7 @@
                   </a:extLst>
                 </a:gridCol>
               </a:tblGrid>
-              <a:tr h="368971">
+              <a:tr h="349665">
                 <a:tc>
                   <a:txBody>
                     <a:bodyPr/>
@@ -7480,7 +7552,7 @@
                   </a:ext>
                 </a:extLst>
               </a:tr>
-              <a:tr h="374095">
+              <a:tr h="456713">
                 <a:tc>
                   <a:txBody>
                     <a:bodyPr/>
@@ -7543,7 +7615,7 @@
                   </a:ext>
                 </a:extLst>
               </a:tr>
-              <a:tr h="374095">
+              <a:tr h="354916">
                 <a:tc>
                   <a:txBody>
                     <a:bodyPr/>
@@ -7606,7 +7678,7 @@
                   </a:ext>
                 </a:extLst>
               </a:tr>
-              <a:tr h="387102">
+              <a:tr h="393945">
                 <a:tc>
                   <a:txBody>
                     <a:bodyPr/>
@@ -7669,7 +7741,7 @@
                   </a:ext>
                 </a:extLst>
               </a:tr>
-              <a:tr h="374095">
+              <a:tr h="354916">
                 <a:tc>
                   <a:txBody>
                     <a:bodyPr/>
@@ -7732,7 +7804,7 @@
                   </a:ext>
                 </a:extLst>
               </a:tr>
-              <a:tr h="374095">
+              <a:tr h="354916">
                 <a:tc>
                   <a:txBody>
                     <a:bodyPr/>
@@ -7795,7 +7867,7 @@
                   </a:ext>
                 </a:extLst>
               </a:tr>
-              <a:tr h="374095">
+              <a:tr h="354916">
                 <a:tc>
                   <a:txBody>
                     <a:bodyPr/>
@@ -7858,7 +7930,7 @@
                   </a:ext>
                 </a:extLst>
               </a:tr>
-              <a:tr h="374095">
+              <a:tr h="354916">
                 <a:tc>
                   <a:txBody>
                     <a:bodyPr/>
@@ -7921,7 +7993,7 @@
                   </a:ext>
                 </a:extLst>
               </a:tr>
-              <a:tr h="374095">
+              <a:tr h="354916">
                 <a:tc>
                   <a:txBody>
                     <a:bodyPr/>
@@ -7973,7 +8045,7 @@
                       <a:pPr algn="ctr"/>
                       <a:r>
                         <a:rPr lang="en-IN" dirty="0"/>
-                        <a:t>336/336, 0 errors</a:t>
+                        <a:t>336/336, 0 fallback</a:t>
                       </a:r>
                     </a:p>
                   </a:txBody>
@@ -8056,7 +8128,7 @@
         </p:nvSpPr>
         <p:spPr bwMode="auto">
           <a:xfrm>
-            <a:off x="609599" y="1166842"/>
+            <a:off x="609601" y="1476662"/>
             <a:ext cx="10972799" cy="4524315"/>
           </a:xfrm>
           <a:prstGeom prst="rect">

</xml_diff>